<commit_message>
dataset preprocessing + tests
</commit_message>
<xml_diff>
--- a/presentations/SARDINE_ICTP_2026-07.pptx
+++ b/presentations/SARDINE_ICTP_2026-07.pptx
@@ -1139,7 +1139,7 @@
           <a:p>
             <a:fld id="{5BCAD085-E8A6-8845-BD4E-CB4CCA059FC4}" type="datetimeFigureOut">
               <a:rPr lang="en-US" smtClean="0"/>
-              <a:t>7/12/2026</a:t>
+              <a:t>7/13/2026</a:t>
             </a:fld>
             <a:endParaRPr lang="en-US"/>
           </a:p>
@@ -1307,7 +1307,7 @@
           <a:p>
             <a:fld id="{5BCAD085-E8A6-8845-BD4E-CB4CCA059FC4}" type="datetimeFigureOut">
               <a:rPr lang="en-US" smtClean="0"/>
-              <a:t>7/12/2026</a:t>
+              <a:t>7/13/2026</a:t>
             </a:fld>
             <a:endParaRPr lang="en-US"/>
           </a:p>
@@ -1485,7 +1485,7 @@
           <a:p>
             <a:fld id="{5BCAD085-E8A6-8845-BD4E-CB4CCA059FC4}" type="datetimeFigureOut">
               <a:rPr lang="en-US" smtClean="0"/>
-              <a:t>7/12/2026</a:t>
+              <a:t>7/13/2026</a:t>
             </a:fld>
             <a:endParaRPr lang="en-US"/>
           </a:p>
@@ -1653,7 +1653,7 @@
           <a:p>
             <a:fld id="{5BCAD085-E8A6-8845-BD4E-CB4CCA059FC4}" type="datetimeFigureOut">
               <a:rPr lang="en-US" smtClean="0"/>
-              <a:t>7/12/2026</a:t>
+              <a:t>7/13/2026</a:t>
             </a:fld>
             <a:endParaRPr lang="en-US"/>
           </a:p>
@@ -1898,7 +1898,7 @@
           <a:p>
             <a:fld id="{5BCAD085-E8A6-8845-BD4E-CB4CCA059FC4}" type="datetimeFigureOut">
               <a:rPr lang="en-US" smtClean="0"/>
-              <a:t>7/12/2026</a:t>
+              <a:t>7/13/2026</a:t>
             </a:fld>
             <a:endParaRPr lang="en-US"/>
           </a:p>
@@ -2183,7 +2183,7 @@
           <a:p>
             <a:fld id="{5BCAD085-E8A6-8845-BD4E-CB4CCA059FC4}" type="datetimeFigureOut">
               <a:rPr lang="en-US" smtClean="0"/>
-              <a:t>7/12/2026</a:t>
+              <a:t>7/13/2026</a:t>
             </a:fld>
             <a:endParaRPr lang="en-US"/>
           </a:p>
@@ -2602,7 +2602,7 @@
           <a:p>
             <a:fld id="{5BCAD085-E8A6-8845-BD4E-CB4CCA059FC4}" type="datetimeFigureOut">
               <a:rPr lang="en-US" smtClean="0"/>
-              <a:t>7/12/2026</a:t>
+              <a:t>7/13/2026</a:t>
             </a:fld>
             <a:endParaRPr lang="en-US"/>
           </a:p>
@@ -2719,7 +2719,7 @@
           <a:p>
             <a:fld id="{5BCAD085-E8A6-8845-BD4E-CB4CCA059FC4}" type="datetimeFigureOut">
               <a:rPr lang="en-US" smtClean="0"/>
-              <a:t>7/12/2026</a:t>
+              <a:t>7/13/2026</a:t>
             </a:fld>
             <a:endParaRPr lang="en-US"/>
           </a:p>
@@ -2814,7 +2814,7 @@
           <a:p>
             <a:fld id="{5BCAD085-E8A6-8845-BD4E-CB4CCA059FC4}" type="datetimeFigureOut">
               <a:rPr lang="en-US" smtClean="0"/>
-              <a:t>7/12/2026</a:t>
+              <a:t>7/13/2026</a:t>
             </a:fld>
             <a:endParaRPr lang="en-US"/>
           </a:p>
@@ -3089,7 +3089,7 @@
           <a:p>
             <a:fld id="{5BCAD085-E8A6-8845-BD4E-CB4CCA059FC4}" type="datetimeFigureOut">
               <a:rPr lang="en-US" smtClean="0"/>
-              <a:t>7/12/2026</a:t>
+              <a:t>7/13/2026</a:t>
             </a:fld>
             <a:endParaRPr lang="en-US"/>
           </a:p>
@@ -3341,7 +3341,7 @@
           <a:p>
             <a:fld id="{5BCAD085-E8A6-8845-BD4E-CB4CCA059FC4}" type="datetimeFigureOut">
               <a:rPr lang="en-US" smtClean="0"/>
-              <a:t>7/12/2026</a:t>
+              <a:t>7/13/2026</a:t>
             </a:fld>
             <a:endParaRPr lang="en-US"/>
           </a:p>
@@ -3552,7 +3552,7 @@
           <a:p>
             <a:fld id="{5BCAD085-E8A6-8845-BD4E-CB4CCA059FC4}" type="datetimeFigureOut">
               <a:rPr lang="en-US" smtClean="0"/>
-              <a:t>7/12/2026</a:t>
+              <a:t>7/13/2026</a:t>
             </a:fld>
             <a:endParaRPr lang="en-US"/>
           </a:p>
@@ -5182,7 +5182,7 @@
         <p:spPr>
           <a:xfrm>
             <a:off x="502920" y="960120"/>
-            <a:ext cx="11155680" cy="457200"/>
+            <a:ext cx="5588581" cy="338554"/>
           </a:xfrm>
           <a:prstGeom prst="rect">
             <a:avLst/>
@@ -5204,6 +5204,7 @@
               </a:defRPr>
             </a:pPr>
             <a:r>
+              <a:rPr sz="1600" dirty="0"/>
               <a:t>FIDE &amp; Google Efficient Chess AI — 5 MiB RAM, 64 KiB binary cap</a:t>
             </a:r>
           </a:p>
@@ -5217,7 +5218,7 @@
         </p:nvSpPr>
         <p:spPr>
           <a:xfrm>
-            <a:off x="502920" y="1417320"/>
+            <a:off x="502920" y="1755648"/>
             <a:ext cx="5394960" cy="1828800"/>
           </a:xfrm>
           <a:prstGeom prst="rect">
@@ -5259,6 +5260,7 @@
               </a:defRPr>
             </a:pPr>
             <a:r>
+              <a:rPr dirty="0"/>
               <a:t>NNUE won at the top</a:t>
             </a:r>
           </a:p>
@@ -5275,6 +5277,11 @@
               </a:defRPr>
             </a:pPr>
             <a:r>
+              <a:rPr dirty="0">
+                <a:solidFill>
+                  <a:schemeClr val="bg1"/>
+                </a:solidFill>
+              </a:rPr>
               <a:t>Micro int8 nets + king mirroring + geometric zeros beat pure HCE for peak Elo.</a:t>
             </a:r>
           </a:p>
@@ -5288,7 +5295,7 @@
         </p:nvSpPr>
         <p:spPr>
           <a:xfrm>
-            <a:off x="6172200" y="1417320"/>
+            <a:off x="6172200" y="1755648"/>
             <a:ext cx="5394960" cy="1828800"/>
           </a:xfrm>
           <a:prstGeom prst="rect">
@@ -5330,6 +5337,7 @@
               </a:defRPr>
             </a:pPr>
             <a:r>
+              <a:rPr dirty="0"/>
               <a:t>RAM = search depth</a:t>
             </a:r>
           </a:p>
@@ -5346,6 +5354,11 @@
               </a:defRPr>
             </a:pPr>
             <a:r>
+              <a:rPr dirty="0">
+                <a:solidFill>
+                  <a:schemeClr val="bg1"/>
+                </a:solidFill>
+              </a:rPr>
               <a:t>Winners gutted history/hash tables to free 512 KB–1 MiB for the transposition table.</a:t>
             </a:r>
           </a:p>
@@ -5359,7 +5372,7 @@
         </p:nvSpPr>
         <p:spPr>
           <a:xfrm>
-            <a:off x="502920" y="3520440"/>
+            <a:off x="502920" y="3858768"/>
             <a:ext cx="5394960" cy="1828800"/>
           </a:xfrm>
           <a:prstGeom prst="rect">
@@ -5401,6 +5414,7 @@
               </a:defRPr>
             </a:pPr>
             <a:r>
+              <a:rPr dirty="0"/>
               <a:t>Buckets help</a:t>
             </a:r>
           </a:p>
@@ -5417,7 +5431,16 @@
               </a:defRPr>
             </a:pPr>
             <a:r>
-              <a:t>2nd place Approvers: 8 output buckets by piece count in ~45 KB net.</a:t>
+              <a:rPr dirty="0">
+                <a:solidFill>
+                  <a:schemeClr val="bg1"/>
+                </a:solidFill>
+              </a:rPr>
+              <a:t>2nd place Approvers: 8 output buckets by piece count in ~45 KB net</a:t>
+            </a:r>
+            <a:r>
+              <a:rPr dirty="0"/>
+              <a:t>.</a:t>
             </a:r>
           </a:p>
         </p:txBody>
@@ -5430,7 +5453,7 @@
         </p:nvSpPr>
         <p:spPr>
           <a:xfrm>
-            <a:off x="6172200" y="3520440"/>
+            <a:off x="6172200" y="3858768"/>
             <a:ext cx="5394960" cy="1828800"/>
           </a:xfrm>
           <a:prstGeom prst="rect">
@@ -5472,6 +5495,7 @@
               </a:defRPr>
             </a:pPr>
             <a:r>
+              <a:rPr dirty="0"/>
               <a:t>C over C++</a:t>
             </a:r>
           </a:p>
@@ -5488,7 +5512,20 @@
               </a:defRPr>
             </a:pPr>
             <a:r>
-              <a:t>Cfish base — lower runtime overhead; informs SARDINE's planned C port.</a:t>
+              <a:rPr dirty="0" err="1">
+                <a:solidFill>
+                  <a:schemeClr val="bg1"/>
+                </a:solidFill>
+              </a:rPr>
+              <a:t>Cfish</a:t>
+            </a:r>
+            <a:r>
+              <a:rPr dirty="0">
+                <a:solidFill>
+                  <a:schemeClr val="bg1"/>
+                </a:solidFill>
+              </a:rPr>
+              <a:t> base — lower runtime overhead; informs SARDINE's planned C port.</a:t>
             </a:r>
           </a:p>
         </p:txBody>
@@ -5534,8 +5571,8 @@
         </p:nvSpPr>
         <p:spPr>
           <a:xfrm>
-            <a:off x="502920" y="320040"/>
-            <a:ext cx="11155680" cy="685800"/>
+            <a:off x="518160" y="1118434"/>
+            <a:ext cx="11155680" cy="1754326"/>
           </a:xfrm>
           <a:prstGeom prst="rect">
             <a:avLst/>
@@ -5557,7 +5594,38 @@
               </a:defRPr>
             </a:pPr>
             <a:r>
-              <a:t>Design Principles We Adopted</a:t>
+              <a:rPr sz="3600" dirty="0"/>
+              <a:t>Design </a:t>
+            </a:r>
+            <a:endParaRPr lang="it-IT" sz="3600" dirty="0"/>
+          </a:p>
+          <a:p>
+            <a:pPr>
+              <a:defRPr sz="3200" b="1">
+                <a:solidFill>
+                  <a:srgbClr val="FFFFFF"/>
+                </a:solidFill>
+                <a:latin typeface="Trebuchet MS"/>
+              </a:defRPr>
+            </a:pPr>
+            <a:r>
+              <a:rPr sz="3600" dirty="0"/>
+              <a:t>Principles </a:t>
+            </a:r>
+            <a:endParaRPr lang="it-IT" sz="3600" dirty="0"/>
+          </a:p>
+          <a:p>
+            <a:pPr>
+              <a:defRPr sz="3200" b="1">
+                <a:solidFill>
+                  <a:srgbClr val="FFFFFF"/>
+                </a:solidFill>
+                <a:latin typeface="Trebuchet MS"/>
+              </a:defRPr>
+            </a:pPr>
+            <a:r>
+              <a:rPr sz="3600" dirty="0"/>
+              <a:t>We Adopted</a:t>
             </a:r>
           </a:p>
         </p:txBody>
@@ -5571,14 +5639,14 @@
           <p:nvPr>
             <p:extLst>
               <p:ext uri="{D42A27DB-BD31-4B8C-83A1-F6EECF244321}">
-                <p14:modId xmlns:p14="http://schemas.microsoft.com/office/powerpoint/2010/main" val="288086067"/>
+                <p14:modId xmlns:p14="http://schemas.microsoft.com/office/powerpoint/2010/main" val="3584752306"/>
               </p:ext>
             </p:extLst>
           </p:nvPr>
         </p:nvGraphicFramePr>
         <p:xfrm>
-          <a:off x="509743" y="1151872"/>
-          <a:ext cx="8661553" cy="3215412"/>
+          <a:off x="4005619" y="12284"/>
+          <a:ext cx="8186382" cy="6845714"/>
         </p:xfrm>
         <a:graphic>
           <a:graphicData uri="http://schemas.openxmlformats.org/drawingml/2006/table">
@@ -5587,21 +5655,21 @@
                 <a:tableStyleId>{5C22544A-7EE6-4342-B048-85BDC9FD1C3A}</a:tableStyleId>
               </a:tblPr>
               <a:tblGrid>
-                <a:gridCol w="2239041">
+                <a:gridCol w="2116208">
                   <a:extLst>
                     <a:ext uri="{9D8B030D-6E8A-4147-A177-3AD203B41FA5}">
                       <a16:colId xmlns:a16="http://schemas.microsoft.com/office/drawing/2014/main" val="20000"/>
                     </a:ext>
                   </a:extLst>
                 </a:gridCol>
-                <a:gridCol w="3063951">
+                <a:gridCol w="2895863">
                   <a:extLst>
                     <a:ext uri="{9D8B030D-6E8A-4147-A177-3AD203B41FA5}">
                       <a16:colId xmlns:a16="http://schemas.microsoft.com/office/drawing/2014/main" val="20001"/>
                     </a:ext>
                   </a:extLst>
                 </a:gridCol>
-                <a:gridCol w="3358561">
+                <a:gridCol w="3174311">
                   <a:extLst>
                     <a:ext uri="{9D8B030D-6E8A-4147-A177-3AD203B41FA5}">
                       <a16:colId xmlns:a16="http://schemas.microsoft.com/office/drawing/2014/main" val="20002"/>
@@ -5609,13 +5677,13 @@
                   </a:extLst>
                 </a:gridCol>
               </a:tblGrid>
-              <a:tr h="492872">
+              <a:tr h="1049340">
                 <a:tc>
                   <a:txBody>
                     <a:bodyPr/>
                     <a:lstStyle/>
                     <a:p>
-                      <a:pPr>
+                      <a:pPr algn="ctr">
                         <a:defRPr sz="1400" b="1">
                           <a:solidFill>
                             <a:srgbClr val="FFFFFF"/>
@@ -5624,7 +5692,7 @@
                         </a:defRPr>
                       </a:pPr>
                       <a:r>
-                        <a:rPr sz="1800"/>
+                        <a:rPr sz="1800" dirty="0"/>
                         <a:t>Principle</a:t>
                       </a:r>
                     </a:p>
@@ -5640,7 +5708,7 @@
                     <a:bodyPr/>
                     <a:lstStyle/>
                     <a:p>
-                      <a:pPr>
+                      <a:pPr algn="ctr">
                         <a:defRPr sz="1400" b="1">
                           <a:solidFill>
                             <a:srgbClr val="FFFFFF"/>
@@ -5665,7 +5733,7 @@
                     <a:bodyPr/>
                     <a:lstStyle/>
                     <a:p>
-                      <a:pPr>
+                      <a:pPr algn="ctr">
                         <a:defRPr sz="1400" b="1">
                           <a:solidFill>
                             <a:srgbClr val="FFFFFF"/>
@@ -5691,13 +5759,13 @@
                   </a:ext>
                 </a:extLst>
               </a:tr>
-              <a:tr h="751045">
+              <a:tr h="1598999">
                 <a:tc>
                   <a:txBody>
                     <a:bodyPr/>
                     <a:lstStyle/>
                     <a:p>
-                      <a:pPr>
+                      <a:pPr algn="ctr">
                         <a:defRPr sz="1300" b="0">
                           <a:solidFill>
                             <a:srgbClr val="CADCFC"/>
@@ -5706,7 +5774,7 @@
                         </a:defRPr>
                       </a:pPr>
                       <a:r>
-                        <a:rPr sz="1600"/>
+                        <a:rPr sz="1600" dirty="0"/>
                         <a:t>Eval</a:t>
                       </a:r>
                     </a:p>
@@ -5722,7 +5790,7 @@
                     <a:bodyPr/>
                     <a:lstStyle/>
                     <a:p>
-                      <a:pPr>
+                      <a:pPr algn="ctr">
                         <a:defRPr sz="1300" b="0">
                           <a:solidFill>
                             <a:srgbClr val="CADCFC"/>
@@ -5747,7 +5815,7 @@
                     <a:bodyPr/>
                     <a:lstStyle/>
                     <a:p>
-                      <a:pPr>
+                      <a:pPr algn="ctr">
                         <a:defRPr sz="1300" b="0">
                           <a:solidFill>
                             <a:srgbClr val="CADCFC"/>
@@ -5773,13 +5841,13 @@
                   </a:ext>
                 </a:extLst>
               </a:tr>
-              <a:tr h="492872">
+              <a:tr h="1049340">
                 <a:tc>
                   <a:txBody>
                     <a:bodyPr/>
                     <a:lstStyle/>
                     <a:p>
-                      <a:pPr>
+                      <a:pPr algn="ctr">
                         <a:defRPr sz="1300" b="0">
                           <a:solidFill>
                             <a:srgbClr val="CADCFC"/>
@@ -5788,7 +5856,7 @@
                         </a:defRPr>
                       </a:pPr>
                       <a:r>
-                        <a:rPr sz="1600"/>
+                        <a:rPr sz="1600" dirty="0"/>
                         <a:t>RAM layout</a:t>
                       </a:r>
                     </a:p>
@@ -5804,7 +5872,7 @@
                     <a:bodyPr/>
                     <a:lstStyle/>
                     <a:p>
-                      <a:pPr>
+                      <a:pPr algn="ctr">
                         <a:defRPr sz="1300" b="0">
                           <a:solidFill>
                             <a:srgbClr val="CADCFC"/>
@@ -5813,7 +5881,7 @@
                         </a:defRPr>
                       </a:pPr>
                       <a:r>
-                        <a:rPr sz="1600"/>
+                        <a:rPr sz="1600" dirty="0"/>
                         <a:t>TT 512 KB – 1 MiB</a:t>
                       </a:r>
                     </a:p>
@@ -5829,7 +5897,7 @@
                     <a:bodyPr/>
                     <a:lstStyle/>
                     <a:p>
-                      <a:pPr>
+                      <a:pPr algn="ctr">
                         <a:defRPr sz="1300" b="0">
                           <a:solidFill>
                             <a:srgbClr val="CADCFC"/>
@@ -5855,13 +5923,13 @@
                   </a:ext>
                 </a:extLst>
               </a:tr>
-              <a:tr h="492872">
+              <a:tr h="1049340">
                 <a:tc>
                   <a:txBody>
                     <a:bodyPr/>
                     <a:lstStyle/>
                     <a:p>
-                      <a:pPr>
+                      <a:pPr algn="ctr">
                         <a:defRPr sz="1300" b="0">
                           <a:solidFill>
                             <a:srgbClr val="CADCFC"/>
@@ -5886,7 +5954,7 @@
                     <a:bodyPr/>
                     <a:lstStyle/>
                     <a:p>
-                      <a:pPr>
+                      <a:pPr algn="ctr">
                         <a:defRPr sz="1300" b="0">
                           <a:solidFill>
                             <a:srgbClr val="CADCFC"/>
@@ -5895,7 +5963,7 @@
                         </a:defRPr>
                       </a:pPr>
                       <a:r>
-                        <a:rPr sz="1600"/>
+                        <a:rPr sz="1600" dirty="0"/>
                         <a:t>King mirror, pawn-rank zeros</a:t>
                       </a:r>
                     </a:p>
@@ -5911,7 +5979,7 @@
                     <a:bodyPr/>
                     <a:lstStyle/>
                     <a:p>
-                      <a:pPr>
+                      <a:pPr algn="ctr">
                         <a:defRPr sz="1300" b="0">
                           <a:solidFill>
                             <a:srgbClr val="CADCFC"/>
@@ -5920,7 +5988,7 @@
                         </a:defRPr>
                       </a:pPr>
                       <a:r>
-                        <a:rPr sz="1600"/>
+                        <a:rPr sz="1600" dirty="0"/>
                         <a:t>Same + gradual L1 prune 70–80%</a:t>
                       </a:r>
                     </a:p>
@@ -5937,13 +6005,13 @@
                   </a:ext>
                 </a:extLst>
               </a:tr>
-              <a:tr h="492872">
+              <a:tr h="1049340">
                 <a:tc>
                   <a:txBody>
                     <a:bodyPr/>
                     <a:lstStyle/>
                     <a:p>
-                      <a:pPr>
+                      <a:pPr algn="ctr">
                         <a:defRPr sz="1300" b="0">
                           <a:solidFill>
                             <a:srgbClr val="CADCFC"/>
@@ -5968,7 +6036,7 @@
                     <a:bodyPr/>
                     <a:lstStyle/>
                     <a:p>
-                      <a:pPr>
+                      <a:pPr algn="ctr">
                         <a:defRPr sz="1300" b="0">
                           <a:solidFill>
                             <a:srgbClr val="CADCFC"/>
@@ -5993,7 +6061,7 @@
                     <a:bodyPr/>
                     <a:lstStyle/>
                     <a:p>
-                      <a:pPr>
+                      <a:pPr algn="ctr">
                         <a:defRPr sz="1300" b="0">
                           <a:solidFill>
                             <a:srgbClr val="CADCFC"/>
@@ -6002,7 +6070,7 @@
                         </a:defRPr>
                       </a:pPr>
                       <a:r>
-                        <a:rPr sz="1600"/>
+                        <a:rPr sz="1600" dirty="0"/>
                         <a:t>C engine after PC bring-up</a:t>
                       </a:r>
                     </a:p>
@@ -6019,13 +6087,13 @@
                   </a:ext>
                 </a:extLst>
               </a:tr>
-              <a:tr h="492879">
+              <a:tr h="1049355">
                 <a:tc>
                   <a:txBody>
                     <a:bodyPr/>
                     <a:lstStyle/>
                     <a:p>
-                      <a:pPr>
+                      <a:pPr algn="ctr">
                         <a:defRPr sz="1300" b="0">
                           <a:solidFill>
                             <a:srgbClr val="CADCFC"/>
@@ -6050,7 +6118,7 @@
                     <a:bodyPr/>
                     <a:lstStyle/>
                     <a:p>
-                      <a:pPr>
+                      <a:pPr algn="ctr">
                         <a:defRPr sz="1300" b="0">
                           <a:solidFill>
                             <a:srgbClr val="CADCFC"/>
@@ -6075,7 +6143,7 @@
                     <a:bodyPr/>
                     <a:lstStyle/>
                     <a:p>
-                      <a:pPr>
+                      <a:pPr algn="ctr">
                         <a:defRPr sz="1300" b="0">
                           <a:solidFill>
                             <a:srgbClr val="CADCFC"/>
@@ -6120,9 +6188,9 @@
           </a:stretch>
         </p:blipFill>
         <p:spPr>
-          <a:xfrm rot="20293236">
-            <a:off x="8959025" y="3906175"/>
-            <a:ext cx="3184851" cy="3184851"/>
+          <a:xfrm rot="2650996">
+            <a:off x="736937" y="3688127"/>
+            <a:ext cx="2570276" cy="2570276"/>
           </a:xfrm>
           <a:prstGeom prst="rect">
             <a:avLst/>
@@ -6171,7 +6239,7 @@
         <p:spPr>
           <a:xfrm>
             <a:off x="345968" y="320040"/>
-            <a:ext cx="11155680" cy="954107"/>
+            <a:ext cx="11155680" cy="1384995"/>
           </a:xfrm>
           <a:prstGeom prst="rect">
             <a:avLst/>
@@ -6201,7 +6269,22 @@
             </a:br>
             <a:r>
               <a:rPr sz="2800" dirty="0"/>
-              <a:t>Bucketed NNUE + </a:t>
+              <a:t>Bucketed </a:t>
+            </a:r>
+            <a:endParaRPr lang="it-IT" sz="2800" dirty="0"/>
+          </a:p>
+          <a:p>
+            <a:pPr>
+              <a:defRPr sz="3200" b="1">
+                <a:solidFill>
+                  <a:srgbClr val="FFFFFF"/>
+                </a:solidFill>
+                <a:latin typeface="Trebuchet MS"/>
+              </a:defRPr>
+            </a:pPr>
+            <a:r>
+              <a:rPr sz="2800" dirty="0"/>
+              <a:t>NNUE + </a:t>
             </a:r>
             <a:r>
               <a:rPr sz="2800" dirty="0" err="1"/>
@@ -6227,8 +6310,8 @@
         </p:blipFill>
         <p:spPr>
           <a:xfrm>
-            <a:off x="4490113" y="1"/>
-            <a:ext cx="7701887" cy="6858000"/>
+            <a:off x="3903260" y="1"/>
+            <a:ext cx="8288741" cy="6858000"/>
           </a:xfrm>
           <a:prstGeom prst="rect">
             <a:avLst/>
@@ -6243,8 +6326,8 @@
         </p:nvSpPr>
         <p:spPr>
           <a:xfrm>
-            <a:off x="441505" y="1632523"/>
-            <a:ext cx="3932602" cy="2021066"/>
+            <a:off x="216318" y="2130667"/>
+            <a:ext cx="3134208" cy="2267287"/>
           </a:xfrm>
           <a:prstGeom prst="rect">
             <a:avLst/>

</xml_diff>